<commit_message>
spec: update brochure to A5 硬卡 format, update demoday PPT
Co-Authored-By: Claude Opus 4.6 (1M context) <noreply@anthropic.com>
</commit_message>
<xml_diff>
--- a/hackathon/ppt/resources/archui-demoday.pptx
+++ b/hackathon/ppt/resources/archui-demoday.pptx
@@ -5,22 +5,18 @@
     <p:sldMasterId id="2147483648" r:id="rId1"/>
   </p:sldMasterIdLst>
   <p:sldIdLst>
-    <p:sldId id="256" r:id="rId7"/>
-    <p:sldId id="257" r:id="rId8"/>
-    <p:sldId id="258" r:id="rId9"/>
-    <p:sldId id="259" r:id="rId10"/>
-    <p:sldId id="260" r:id="rId11"/>
-    <p:sldId id="261" r:id="rId12"/>
-    <p:sldId id="262" r:id="rId13"/>
-    <p:sldId id="263" r:id="rId14"/>
-    <p:sldId id="264" r:id="rId15"/>
-    <p:sldId id="265" r:id="rId16"/>
-    <p:sldId id="266" r:id="rId17"/>
-    <p:sldId id="267" r:id="rId18"/>
-    <p:sldId id="268" r:id="rId19"/>
-    <p:sldId id="269" r:id="rId20"/>
+    <p:sldId id="256" r:id="rId2"/>
+    <p:sldId id="257" r:id="rId3"/>
+    <p:sldId id="258" r:id="rId4"/>
+    <p:sldId id="259" r:id="rId5"/>
+    <p:sldId id="260" r:id="rId6"/>
+    <p:sldId id="261" r:id="rId7"/>
+    <p:sldId id="262" r:id="rId8"/>
+    <p:sldId id="263" r:id="rId9"/>
+    <p:sldId id="268" r:id="rId10"/>
+    <p:sldId id="269" r:id="rId11"/>
   </p:sldIdLst>
-  <p:sldSz cx="31320000" cy="7560000" type="screen4x3"/>
+  <p:sldSz cx="31319788" cy="7559675"/>
   <p:notesSz cx="6858000" cy="9144000"/>
   <p:defaultTextStyle>
     <a:defPPr>
@@ -117,6 +113,22 @@
       </a:defRPr>
     </a:lvl9pPr>
   </p:defaultTextStyle>
+  <p:extLst>
+    <p:ext uri="{EFAFB233-063F-42B5-8137-9DF3F51BA10A}">
+      <p15:sldGuideLst xmlns:p15="http://schemas.microsoft.com/office/powerpoint/2012/main">
+        <p15:guide id="1" orient="horz" pos="2160">
+          <p15:clr>
+            <a:srgbClr val="A4A3A4"/>
+          </p15:clr>
+        </p15:guide>
+        <p15:guide id="2" pos="2880">
+          <p15:clr>
+            <a:srgbClr val="A4A3A4"/>
+          </p15:clr>
+        </p15:guide>
+      </p15:sldGuideLst>
+    </p:ext>
+  </p:extLst>
 </p:presentation>
 </file>
 
@@ -158,10 +170,9 @@
           <a:lstStyle/>
           <a:p>
             <a:r>
-              <a:rPr lang="en-US" smtClean="0"/>
+              <a:rPr lang="en-US"/>
               <a:t>Click to edit Master title style</a:t>
             </a:r>
-            <a:endParaRPr lang="en-US"/>
           </a:p>
         </p:txBody>
       </p:sp>
@@ -277,10 +288,9 @@
           </a:lstStyle>
           <a:p>
             <a:r>
-              <a:rPr lang="en-US" smtClean="0"/>
+              <a:rPr lang="en-US"/>
               <a:t>Click to edit Master subtitle style</a:t>
             </a:r>
-            <a:endParaRPr lang="en-US"/>
           </a:p>
         </p:txBody>
       </p:sp>
@@ -301,7 +311,7 @@
           <a:p>
             <a:fld id="{5BCAD085-E8A6-8845-BD4E-CB4CCA059FC4}" type="datetimeFigureOut">
               <a:rPr lang="en-US" smtClean="0"/>
-              <a:t>1/27/13</a:t>
+              <a:t>4/8/26</a:t>
             </a:fld>
             <a:endParaRPr lang="en-US"/>
           </a:p>
@@ -395,10 +405,9 @@
           <a:lstStyle/>
           <a:p>
             <a:r>
-              <a:rPr lang="en-US" smtClean="0"/>
+              <a:rPr lang="en-US"/>
               <a:t>Click to edit Master title style</a:t>
             </a:r>
-            <a:endParaRPr lang="en-US"/>
           </a:p>
         </p:txBody>
       </p:sp>
@@ -419,38 +428,37 @@
           <a:p>
             <a:pPr lvl="0"/>
             <a:r>
-              <a:rPr lang="en-US" smtClean="0"/>
+              <a:rPr lang="en-US"/>
               <a:t>Click to edit Master text styles</a:t>
             </a:r>
           </a:p>
           <a:p>
             <a:pPr lvl="1"/>
             <a:r>
-              <a:rPr lang="en-US" smtClean="0"/>
+              <a:rPr lang="en-US"/>
               <a:t>Second level</a:t>
             </a:r>
           </a:p>
           <a:p>
             <a:pPr lvl="2"/>
             <a:r>
-              <a:rPr lang="en-US" smtClean="0"/>
+              <a:rPr lang="en-US"/>
               <a:t>Third level</a:t>
             </a:r>
           </a:p>
           <a:p>
             <a:pPr lvl="3"/>
             <a:r>
-              <a:rPr lang="en-US" smtClean="0"/>
+              <a:rPr lang="en-US"/>
               <a:t>Fourth level</a:t>
             </a:r>
           </a:p>
           <a:p>
             <a:pPr lvl="4"/>
             <a:r>
-              <a:rPr lang="en-US" smtClean="0"/>
+              <a:rPr lang="en-US"/>
               <a:t>Fifth level</a:t>
             </a:r>
-            <a:endParaRPr lang="en-US"/>
           </a:p>
         </p:txBody>
       </p:sp>
@@ -471,7 +479,7 @@
           <a:p>
             <a:fld id="{5BCAD085-E8A6-8845-BD4E-CB4CCA059FC4}" type="datetimeFigureOut">
               <a:rPr lang="en-US" smtClean="0"/>
-              <a:t>1/27/13</a:t>
+              <a:t>4/8/26</a:t>
             </a:fld>
             <a:endParaRPr lang="en-US"/>
           </a:p>
@@ -570,10 +578,9 @@
           <a:lstStyle/>
           <a:p>
             <a:r>
-              <a:rPr lang="en-US" smtClean="0"/>
+              <a:rPr lang="en-US"/>
               <a:t>Click to edit Master title style</a:t>
             </a:r>
-            <a:endParaRPr lang="en-US"/>
           </a:p>
         </p:txBody>
       </p:sp>
@@ -599,38 +606,37 @@
           <a:p>
             <a:pPr lvl="0"/>
             <a:r>
-              <a:rPr lang="en-US" smtClean="0"/>
+              <a:rPr lang="en-US"/>
               <a:t>Click to edit Master text styles</a:t>
             </a:r>
           </a:p>
           <a:p>
             <a:pPr lvl="1"/>
             <a:r>
-              <a:rPr lang="en-US" smtClean="0"/>
+              <a:rPr lang="en-US"/>
               <a:t>Second level</a:t>
             </a:r>
           </a:p>
           <a:p>
             <a:pPr lvl="2"/>
             <a:r>
-              <a:rPr lang="en-US" smtClean="0"/>
+              <a:rPr lang="en-US"/>
               <a:t>Third level</a:t>
             </a:r>
           </a:p>
           <a:p>
             <a:pPr lvl="3"/>
             <a:r>
-              <a:rPr lang="en-US" smtClean="0"/>
+              <a:rPr lang="en-US"/>
               <a:t>Fourth level</a:t>
             </a:r>
           </a:p>
           <a:p>
             <a:pPr lvl="4"/>
             <a:r>
-              <a:rPr lang="en-US" smtClean="0"/>
+              <a:rPr lang="en-US"/>
               <a:t>Fifth level</a:t>
             </a:r>
-            <a:endParaRPr lang="en-US"/>
           </a:p>
         </p:txBody>
       </p:sp>
@@ -651,7 +657,7 @@
           <a:p>
             <a:fld id="{5BCAD085-E8A6-8845-BD4E-CB4CCA059FC4}" type="datetimeFigureOut">
               <a:rPr lang="en-US" smtClean="0"/>
-              <a:t>1/27/13</a:t>
+              <a:t>4/8/26</a:t>
             </a:fld>
             <a:endParaRPr lang="en-US"/>
           </a:p>
@@ -745,10 +751,9 @@
           <a:lstStyle/>
           <a:p>
             <a:r>
-              <a:rPr lang="en-US" smtClean="0"/>
+              <a:rPr lang="en-US"/>
               <a:t>Click to edit Master title style</a:t>
             </a:r>
-            <a:endParaRPr lang="en-US"/>
           </a:p>
         </p:txBody>
       </p:sp>
@@ -769,38 +774,37 @@
           <a:p>
             <a:pPr lvl="0"/>
             <a:r>
-              <a:rPr lang="en-US" smtClean="0"/>
+              <a:rPr lang="en-US"/>
               <a:t>Click to edit Master text styles</a:t>
             </a:r>
           </a:p>
           <a:p>
             <a:pPr lvl="1"/>
             <a:r>
-              <a:rPr lang="en-US" smtClean="0"/>
+              <a:rPr lang="en-US"/>
               <a:t>Second level</a:t>
             </a:r>
           </a:p>
           <a:p>
             <a:pPr lvl="2"/>
             <a:r>
-              <a:rPr lang="en-US" smtClean="0"/>
+              <a:rPr lang="en-US"/>
               <a:t>Third level</a:t>
             </a:r>
           </a:p>
           <a:p>
             <a:pPr lvl="3"/>
             <a:r>
-              <a:rPr lang="en-US" smtClean="0"/>
+              <a:rPr lang="en-US"/>
               <a:t>Fourth level</a:t>
             </a:r>
           </a:p>
           <a:p>
             <a:pPr lvl="4"/>
             <a:r>
-              <a:rPr lang="en-US" smtClean="0"/>
+              <a:rPr lang="en-US"/>
               <a:t>Fifth level</a:t>
             </a:r>
-            <a:endParaRPr lang="en-US"/>
           </a:p>
         </p:txBody>
       </p:sp>
@@ -821,7 +825,7 @@
           <a:p>
             <a:fld id="{5BCAD085-E8A6-8845-BD4E-CB4CCA059FC4}" type="datetimeFigureOut">
               <a:rPr lang="en-US" smtClean="0"/>
-              <a:t>1/27/13</a:t>
+              <a:t>4/8/26</a:t>
             </a:fld>
             <a:endParaRPr lang="en-US"/>
           </a:p>
@@ -924,10 +928,9 @@
           </a:lstStyle>
           <a:p>
             <a:r>
-              <a:rPr lang="en-US" smtClean="0"/>
+              <a:rPr lang="en-US"/>
               <a:t>Click to edit Master title style</a:t>
             </a:r>
-            <a:endParaRPr lang="en-US"/>
           </a:p>
         </p:txBody>
       </p:sp>
@@ -1044,7 +1047,7 @@
           <a:p>
             <a:pPr lvl="0"/>
             <a:r>
-              <a:rPr lang="en-US" smtClean="0"/>
+              <a:rPr lang="en-US"/>
               <a:t>Click to edit Master text styles</a:t>
             </a:r>
           </a:p>
@@ -1067,7 +1070,7 @@
           <a:p>
             <a:fld id="{5BCAD085-E8A6-8845-BD4E-CB4CCA059FC4}" type="datetimeFigureOut">
               <a:rPr lang="en-US" smtClean="0"/>
-              <a:t>1/27/13</a:t>
+              <a:t>4/8/26</a:t>
             </a:fld>
             <a:endParaRPr lang="en-US"/>
           </a:p>
@@ -1161,10 +1164,9 @@
           <a:lstStyle/>
           <a:p>
             <a:r>
-              <a:rPr lang="en-US" smtClean="0"/>
+              <a:rPr lang="en-US"/>
               <a:t>Click to edit Master title style</a:t>
             </a:r>
-            <a:endParaRPr lang="en-US"/>
           </a:p>
         </p:txBody>
       </p:sp>
@@ -1218,38 +1220,37 @@
           <a:p>
             <a:pPr lvl="0"/>
             <a:r>
-              <a:rPr lang="en-US" smtClean="0"/>
+              <a:rPr lang="en-US"/>
               <a:t>Click to edit Master text styles</a:t>
             </a:r>
           </a:p>
           <a:p>
             <a:pPr lvl="1"/>
             <a:r>
-              <a:rPr lang="en-US" smtClean="0"/>
+              <a:rPr lang="en-US"/>
               <a:t>Second level</a:t>
             </a:r>
           </a:p>
           <a:p>
             <a:pPr lvl="2"/>
             <a:r>
-              <a:rPr lang="en-US" smtClean="0"/>
+              <a:rPr lang="en-US"/>
               <a:t>Third level</a:t>
             </a:r>
           </a:p>
           <a:p>
             <a:pPr lvl="3"/>
             <a:r>
-              <a:rPr lang="en-US" smtClean="0"/>
+              <a:rPr lang="en-US"/>
               <a:t>Fourth level</a:t>
             </a:r>
           </a:p>
           <a:p>
             <a:pPr lvl="4"/>
             <a:r>
-              <a:rPr lang="en-US" smtClean="0"/>
+              <a:rPr lang="en-US"/>
               <a:t>Fifth level</a:t>
             </a:r>
-            <a:endParaRPr lang="en-US"/>
           </a:p>
         </p:txBody>
       </p:sp>
@@ -1303,38 +1304,37 @@
           <a:p>
             <a:pPr lvl="0"/>
             <a:r>
-              <a:rPr lang="en-US" smtClean="0"/>
+              <a:rPr lang="en-US"/>
               <a:t>Click to edit Master text styles</a:t>
             </a:r>
           </a:p>
           <a:p>
             <a:pPr lvl="1"/>
             <a:r>
-              <a:rPr lang="en-US" smtClean="0"/>
+              <a:rPr lang="en-US"/>
               <a:t>Second level</a:t>
             </a:r>
           </a:p>
           <a:p>
             <a:pPr lvl="2"/>
             <a:r>
-              <a:rPr lang="en-US" smtClean="0"/>
+              <a:rPr lang="en-US"/>
               <a:t>Third level</a:t>
             </a:r>
           </a:p>
           <a:p>
             <a:pPr lvl="3"/>
             <a:r>
-              <a:rPr lang="en-US" smtClean="0"/>
+              <a:rPr lang="en-US"/>
               <a:t>Fourth level</a:t>
             </a:r>
           </a:p>
           <a:p>
             <a:pPr lvl="4"/>
             <a:r>
-              <a:rPr lang="en-US" smtClean="0"/>
+              <a:rPr lang="en-US"/>
               <a:t>Fifth level</a:t>
             </a:r>
-            <a:endParaRPr lang="en-US"/>
           </a:p>
         </p:txBody>
       </p:sp>
@@ -1355,7 +1355,7 @@
           <a:p>
             <a:fld id="{5BCAD085-E8A6-8845-BD4E-CB4CCA059FC4}" type="datetimeFigureOut">
               <a:rPr lang="en-US" smtClean="0"/>
-              <a:t>1/27/13</a:t>
+              <a:t>4/8/26</a:t>
             </a:fld>
             <a:endParaRPr lang="en-US"/>
           </a:p>
@@ -1453,10 +1453,9 @@
           </a:lstStyle>
           <a:p>
             <a:r>
-              <a:rPr lang="en-US" smtClean="0"/>
+              <a:rPr lang="en-US"/>
               <a:t>Click to edit Master title style</a:t>
             </a:r>
-            <a:endParaRPr lang="en-US"/>
           </a:p>
         </p:txBody>
       </p:sp>
@@ -1519,7 +1518,7 @@
           <a:p>
             <a:pPr lvl="0"/>
             <a:r>
-              <a:rPr lang="en-US" smtClean="0"/>
+              <a:rPr lang="en-US"/>
               <a:t>Click to edit Master text styles</a:t>
             </a:r>
           </a:p>
@@ -1575,38 +1574,37 @@
           <a:p>
             <a:pPr lvl="0"/>
             <a:r>
-              <a:rPr lang="en-US" smtClean="0"/>
+              <a:rPr lang="en-US"/>
               <a:t>Click to edit Master text styles</a:t>
             </a:r>
           </a:p>
           <a:p>
             <a:pPr lvl="1"/>
             <a:r>
-              <a:rPr lang="en-US" smtClean="0"/>
+              <a:rPr lang="en-US"/>
               <a:t>Second level</a:t>
             </a:r>
           </a:p>
           <a:p>
             <a:pPr lvl="2"/>
             <a:r>
-              <a:rPr lang="en-US" smtClean="0"/>
+              <a:rPr lang="en-US"/>
               <a:t>Third level</a:t>
             </a:r>
           </a:p>
           <a:p>
             <a:pPr lvl="3"/>
             <a:r>
-              <a:rPr lang="en-US" smtClean="0"/>
+              <a:rPr lang="en-US"/>
               <a:t>Fourth level</a:t>
             </a:r>
           </a:p>
           <a:p>
             <a:pPr lvl="4"/>
             <a:r>
-              <a:rPr lang="en-US" smtClean="0"/>
+              <a:rPr lang="en-US"/>
               <a:t>Fifth level</a:t>
             </a:r>
-            <a:endParaRPr lang="en-US"/>
           </a:p>
         </p:txBody>
       </p:sp>
@@ -1669,7 +1667,7 @@
           <a:p>
             <a:pPr lvl="0"/>
             <a:r>
-              <a:rPr lang="en-US" smtClean="0"/>
+              <a:rPr lang="en-US"/>
               <a:t>Click to edit Master text styles</a:t>
             </a:r>
           </a:p>
@@ -1725,38 +1723,37 @@
           <a:p>
             <a:pPr lvl="0"/>
             <a:r>
-              <a:rPr lang="en-US" smtClean="0"/>
+              <a:rPr lang="en-US"/>
               <a:t>Click to edit Master text styles</a:t>
             </a:r>
           </a:p>
           <a:p>
             <a:pPr lvl="1"/>
             <a:r>
-              <a:rPr lang="en-US" smtClean="0"/>
+              <a:rPr lang="en-US"/>
               <a:t>Second level</a:t>
             </a:r>
           </a:p>
           <a:p>
             <a:pPr lvl="2"/>
             <a:r>
-              <a:rPr lang="en-US" smtClean="0"/>
+              <a:rPr lang="en-US"/>
               <a:t>Third level</a:t>
             </a:r>
           </a:p>
           <a:p>
             <a:pPr lvl="3"/>
             <a:r>
-              <a:rPr lang="en-US" smtClean="0"/>
+              <a:rPr lang="en-US"/>
               <a:t>Fourth level</a:t>
             </a:r>
           </a:p>
           <a:p>
             <a:pPr lvl="4"/>
             <a:r>
-              <a:rPr lang="en-US" smtClean="0"/>
+              <a:rPr lang="en-US"/>
               <a:t>Fifth level</a:t>
             </a:r>
-            <a:endParaRPr lang="en-US"/>
           </a:p>
         </p:txBody>
       </p:sp>
@@ -1777,7 +1774,7 @@
           <a:p>
             <a:fld id="{5BCAD085-E8A6-8845-BD4E-CB4CCA059FC4}" type="datetimeFigureOut">
               <a:rPr lang="en-US" smtClean="0"/>
-              <a:t>1/27/13</a:t>
+              <a:t>4/8/26</a:t>
             </a:fld>
             <a:endParaRPr lang="en-US"/>
           </a:p>
@@ -1871,10 +1868,9 @@
           <a:lstStyle/>
           <a:p>
             <a:r>
-              <a:rPr lang="en-US" smtClean="0"/>
+              <a:rPr lang="en-US"/>
               <a:t>Click to edit Master title style</a:t>
             </a:r>
-            <a:endParaRPr lang="en-US"/>
           </a:p>
         </p:txBody>
       </p:sp>
@@ -1895,7 +1891,7 @@
           <a:p>
             <a:fld id="{5BCAD085-E8A6-8845-BD4E-CB4CCA059FC4}" type="datetimeFigureOut">
               <a:rPr lang="en-US" smtClean="0"/>
-              <a:t>1/27/13</a:t>
+              <a:t>4/8/26</a:t>
             </a:fld>
             <a:endParaRPr lang="en-US"/>
           </a:p>
@@ -1990,7 +1986,7 @@
           <a:p>
             <a:fld id="{5BCAD085-E8A6-8845-BD4E-CB4CCA059FC4}" type="datetimeFigureOut">
               <a:rPr lang="en-US" smtClean="0"/>
-              <a:t>1/27/13</a:t>
+              <a:t>4/8/26</a:t>
             </a:fld>
             <a:endParaRPr lang="en-US"/>
           </a:p>
@@ -2093,10 +2089,9 @@
           </a:lstStyle>
           <a:p>
             <a:r>
-              <a:rPr lang="en-US" smtClean="0"/>
+              <a:rPr lang="en-US"/>
               <a:t>Click to edit Master title style</a:t>
             </a:r>
-            <a:endParaRPr lang="en-US"/>
           </a:p>
         </p:txBody>
       </p:sp>
@@ -2150,38 +2145,37 @@
           <a:p>
             <a:pPr lvl="0"/>
             <a:r>
-              <a:rPr lang="en-US" smtClean="0"/>
+              <a:rPr lang="en-US"/>
               <a:t>Click to edit Master text styles</a:t>
             </a:r>
           </a:p>
           <a:p>
             <a:pPr lvl="1"/>
             <a:r>
-              <a:rPr lang="en-US" smtClean="0"/>
+              <a:rPr lang="en-US"/>
               <a:t>Second level</a:t>
             </a:r>
           </a:p>
           <a:p>
             <a:pPr lvl="2"/>
             <a:r>
-              <a:rPr lang="en-US" smtClean="0"/>
+              <a:rPr lang="en-US"/>
               <a:t>Third level</a:t>
             </a:r>
           </a:p>
           <a:p>
             <a:pPr lvl="3"/>
             <a:r>
-              <a:rPr lang="en-US" smtClean="0"/>
+              <a:rPr lang="en-US"/>
               <a:t>Fourth level</a:t>
             </a:r>
           </a:p>
           <a:p>
             <a:pPr lvl="4"/>
             <a:r>
-              <a:rPr lang="en-US" smtClean="0"/>
+              <a:rPr lang="en-US"/>
               <a:t>Fifth level</a:t>
             </a:r>
-            <a:endParaRPr lang="en-US"/>
           </a:p>
         </p:txBody>
       </p:sp>
@@ -2244,7 +2238,7 @@
           <a:p>
             <a:pPr lvl="0"/>
             <a:r>
-              <a:rPr lang="en-US" smtClean="0"/>
+              <a:rPr lang="en-US"/>
               <a:t>Click to edit Master text styles</a:t>
             </a:r>
           </a:p>
@@ -2267,7 +2261,7 @@
           <a:p>
             <a:fld id="{5BCAD085-E8A6-8845-BD4E-CB4CCA059FC4}" type="datetimeFigureOut">
               <a:rPr lang="en-US" smtClean="0"/>
-              <a:t>1/27/13</a:t>
+              <a:t>4/8/26</a:t>
             </a:fld>
             <a:endParaRPr lang="en-US"/>
           </a:p>
@@ -2370,10 +2364,9 @@
           </a:lstStyle>
           <a:p>
             <a:r>
-              <a:rPr lang="en-US" smtClean="0"/>
+              <a:rPr lang="en-US"/>
               <a:t>Click to edit Master title style</a:t>
             </a:r>
-            <a:endParaRPr lang="en-US"/>
           </a:p>
         </p:txBody>
       </p:sp>
@@ -2497,7 +2490,7 @@
           <a:p>
             <a:pPr lvl="0"/>
             <a:r>
-              <a:rPr lang="en-US" smtClean="0"/>
+              <a:rPr lang="en-US"/>
               <a:t>Click to edit Master text styles</a:t>
             </a:r>
           </a:p>
@@ -2520,7 +2513,7 @@
           <a:p>
             <a:fld id="{5BCAD085-E8A6-8845-BD4E-CB4CCA059FC4}" type="datetimeFigureOut">
               <a:rPr lang="en-US" smtClean="0"/>
-              <a:t>1/27/13</a:t>
+              <a:t>4/8/26</a:t>
             </a:fld>
             <a:endParaRPr lang="en-US"/>
           </a:p>
@@ -2629,10 +2622,9 @@
           <a:lstStyle/>
           <a:p>
             <a:r>
-              <a:rPr lang="en-US" smtClean="0"/>
+              <a:rPr lang="en-US"/>
               <a:t>Click to edit Master title style</a:t>
             </a:r>
-            <a:endParaRPr lang="en-US"/>
           </a:p>
         </p:txBody>
       </p:sp>
@@ -2663,38 +2655,37 @@
           <a:p>
             <a:pPr lvl="0"/>
             <a:r>
-              <a:rPr lang="en-US" smtClean="0"/>
+              <a:rPr lang="en-US"/>
               <a:t>Click to edit Master text styles</a:t>
             </a:r>
           </a:p>
           <a:p>
             <a:pPr lvl="1"/>
             <a:r>
-              <a:rPr lang="en-US" smtClean="0"/>
+              <a:rPr lang="en-US"/>
               <a:t>Second level</a:t>
             </a:r>
           </a:p>
           <a:p>
             <a:pPr lvl="2"/>
             <a:r>
-              <a:rPr lang="en-US" smtClean="0"/>
+              <a:rPr lang="en-US"/>
               <a:t>Third level</a:t>
             </a:r>
           </a:p>
           <a:p>
             <a:pPr lvl="3"/>
             <a:r>
-              <a:rPr lang="en-US" smtClean="0"/>
+              <a:rPr lang="en-US"/>
               <a:t>Fourth level</a:t>
             </a:r>
           </a:p>
           <a:p>
             <a:pPr lvl="4"/>
             <a:r>
-              <a:rPr lang="en-US" smtClean="0"/>
+              <a:rPr lang="en-US"/>
               <a:t>Fifth level</a:t>
             </a:r>
-            <a:endParaRPr lang="en-US"/>
           </a:p>
         </p:txBody>
       </p:sp>
@@ -2733,7 +2724,7 @@
           <a:p>
             <a:fld id="{5BCAD085-E8A6-8845-BD4E-CB4CCA059FC4}" type="datetimeFigureOut">
               <a:rPr lang="en-US" smtClean="0"/>
-              <a:t>1/27/13</a:t>
+              <a:t>4/8/26</a:t>
             </a:fld>
             <a:endParaRPr lang="en-US"/>
           </a:p>
@@ -3092,7 +3083,7 @@
 </file>
 
 <file path=ppt/slides/slide1.xml><?xml version="1.0" encoding="utf-8"?>
-<p:sld xmlns:a="http://schemas.openxmlformats.org/drawingml/2006/main" xmlns:p="http://schemas.openxmlformats.org/presentationml/2006/main" xmlns:r="http://schemas.openxmlformats.org/officeDocument/2006/relationships">
+<p:sld xmlns:a="http://schemas.openxmlformats.org/drawingml/2006/main" xmlns:r="http://schemas.openxmlformats.org/officeDocument/2006/relationships" xmlns:p="http://schemas.openxmlformats.org/presentationml/2006/main">
   <p:cSld>
     <p:spTree>
       <p:nvGrpSpPr>
@@ -3100,7 +3091,14 @@
         <p:cNvGrpSpPr/>
         <p:nvPr/>
       </p:nvGrpSpPr>
-      <p:grpSpPr/>
+      <p:grpSpPr>
+        <a:xfrm>
+          <a:off x="0" y="0"/>
+          <a:ext cx="0" cy="0"/>
+          <a:chOff x="0" y="0"/>
+          <a:chExt cx="0" cy="0"/>
+        </a:xfrm>
+      </p:grpSpPr>
       <p:pic>
         <p:nvPicPr>
           <p:cNvPr id="2" name="Picture 1" descr="slide_01.png"/>
@@ -3134,7 +3132,7 @@
 </file>
 
 <file path=ppt/slides/slide10.xml><?xml version="1.0" encoding="utf-8"?>
-<p:sld xmlns:a="http://schemas.openxmlformats.org/drawingml/2006/main" xmlns:p="http://schemas.openxmlformats.org/presentationml/2006/main" xmlns:r="http://schemas.openxmlformats.org/officeDocument/2006/relationships">
+<p:sld xmlns:a="http://schemas.openxmlformats.org/drawingml/2006/main" xmlns:r="http://schemas.openxmlformats.org/officeDocument/2006/relationships" xmlns:p="http://schemas.openxmlformats.org/presentationml/2006/main">
   <p:cSld>
     <p:spTree>
       <p:nvGrpSpPr>
@@ -3142,175 +3140,14 @@
         <p:cNvGrpSpPr/>
         <p:nvPr/>
       </p:nvGrpSpPr>
-      <p:grpSpPr/>
-      <p:pic>
-        <p:nvPicPr>
-          <p:cNvPr id="2" name="Picture 1" descr="slide_10.png"/>
-          <p:cNvPicPr>
-            <a:picLocks noChangeAspect="1"/>
-          </p:cNvPicPr>
-          <p:nvPr/>
-        </p:nvPicPr>
-        <p:blipFill>
-          <a:blip r:embed="rId2"/>
-          <a:stretch>
-            <a:fillRect/>
-          </a:stretch>
-        </p:blipFill>
-        <p:spPr>
-          <a:xfrm>
-            <a:off x="0" y="0"/>
-            <a:ext cx="31320000" cy="7560000"/>
-          </a:xfrm>
-          <a:prstGeom prst="rect">
-            <a:avLst/>
-          </a:prstGeom>
-        </p:spPr>
-      </p:pic>
-    </p:spTree>
-  </p:cSld>
-  <p:clrMapOvr>
-    <a:masterClrMapping/>
-  </p:clrMapOvr>
-</p:sld>
-</file>
-
-<file path=ppt/slides/slide11.xml><?xml version="1.0" encoding="utf-8"?>
-<p:sld xmlns:a="http://schemas.openxmlformats.org/drawingml/2006/main" xmlns:p="http://schemas.openxmlformats.org/presentationml/2006/main" xmlns:r="http://schemas.openxmlformats.org/officeDocument/2006/relationships">
-  <p:cSld>
-    <p:spTree>
-      <p:nvGrpSpPr>
-        <p:cNvPr id="1" name=""/>
-        <p:cNvGrpSpPr/>
-        <p:nvPr/>
-      </p:nvGrpSpPr>
-      <p:grpSpPr/>
-      <p:pic>
-        <p:nvPicPr>
-          <p:cNvPr id="2" name="Picture 1" descr="slide_11.png"/>
-          <p:cNvPicPr>
-            <a:picLocks noChangeAspect="1"/>
-          </p:cNvPicPr>
-          <p:nvPr/>
-        </p:nvPicPr>
-        <p:blipFill>
-          <a:blip r:embed="rId2"/>
-          <a:stretch>
-            <a:fillRect/>
-          </a:stretch>
-        </p:blipFill>
-        <p:spPr>
-          <a:xfrm>
-            <a:off x="0" y="0"/>
-            <a:ext cx="31320000" cy="7560000"/>
-          </a:xfrm>
-          <a:prstGeom prst="rect">
-            <a:avLst/>
-          </a:prstGeom>
-        </p:spPr>
-      </p:pic>
-    </p:spTree>
-  </p:cSld>
-  <p:clrMapOvr>
-    <a:masterClrMapping/>
-  </p:clrMapOvr>
-</p:sld>
-</file>
-
-<file path=ppt/slides/slide12.xml><?xml version="1.0" encoding="utf-8"?>
-<p:sld xmlns:a="http://schemas.openxmlformats.org/drawingml/2006/main" xmlns:p="http://schemas.openxmlformats.org/presentationml/2006/main" xmlns:r="http://schemas.openxmlformats.org/officeDocument/2006/relationships">
-  <p:cSld>
-    <p:spTree>
-      <p:nvGrpSpPr>
-        <p:cNvPr id="1" name=""/>
-        <p:cNvGrpSpPr/>
-        <p:nvPr/>
-      </p:nvGrpSpPr>
-      <p:grpSpPr/>
-      <p:pic>
-        <p:nvPicPr>
-          <p:cNvPr id="2" name="Picture 1" descr="slide_12.png"/>
-          <p:cNvPicPr>
-            <a:picLocks noChangeAspect="1"/>
-          </p:cNvPicPr>
-          <p:nvPr/>
-        </p:nvPicPr>
-        <p:blipFill>
-          <a:blip r:embed="rId2"/>
-          <a:stretch>
-            <a:fillRect/>
-          </a:stretch>
-        </p:blipFill>
-        <p:spPr>
-          <a:xfrm>
-            <a:off x="0" y="0"/>
-            <a:ext cx="31320000" cy="7560000"/>
-          </a:xfrm>
-          <a:prstGeom prst="rect">
-            <a:avLst/>
-          </a:prstGeom>
-        </p:spPr>
-      </p:pic>
-    </p:spTree>
-  </p:cSld>
-  <p:clrMapOvr>
-    <a:masterClrMapping/>
-  </p:clrMapOvr>
-</p:sld>
-</file>
-
-<file path=ppt/slides/slide13.xml><?xml version="1.0" encoding="utf-8"?>
-<p:sld xmlns:a="http://schemas.openxmlformats.org/drawingml/2006/main" xmlns:p="http://schemas.openxmlformats.org/presentationml/2006/main" xmlns:r="http://schemas.openxmlformats.org/officeDocument/2006/relationships">
-  <p:cSld>
-    <p:spTree>
-      <p:nvGrpSpPr>
-        <p:cNvPr id="1" name=""/>
-        <p:cNvGrpSpPr/>
-        <p:nvPr/>
-      </p:nvGrpSpPr>
-      <p:grpSpPr/>
-      <p:pic>
-        <p:nvPicPr>
-          <p:cNvPr id="2" name="Picture 1" descr="slide_13.png"/>
-          <p:cNvPicPr>
-            <a:picLocks noChangeAspect="1"/>
-          </p:cNvPicPr>
-          <p:nvPr/>
-        </p:nvPicPr>
-        <p:blipFill>
-          <a:blip r:embed="rId2"/>
-          <a:stretch>
-            <a:fillRect/>
-          </a:stretch>
-        </p:blipFill>
-        <p:spPr>
-          <a:xfrm>
-            <a:off x="0" y="0"/>
-            <a:ext cx="31320000" cy="7560000"/>
-          </a:xfrm>
-          <a:prstGeom prst="rect">
-            <a:avLst/>
-          </a:prstGeom>
-        </p:spPr>
-      </p:pic>
-    </p:spTree>
-  </p:cSld>
-  <p:clrMapOvr>
-    <a:masterClrMapping/>
-  </p:clrMapOvr>
-</p:sld>
-</file>
-
-<file path=ppt/slides/slide14.xml><?xml version="1.0" encoding="utf-8"?>
-<p:sld xmlns:a="http://schemas.openxmlformats.org/drawingml/2006/main" xmlns:p="http://schemas.openxmlformats.org/presentationml/2006/main" xmlns:r="http://schemas.openxmlformats.org/officeDocument/2006/relationships">
-  <p:cSld>
-    <p:spTree>
-      <p:nvGrpSpPr>
-        <p:cNvPr id="1" name=""/>
-        <p:cNvGrpSpPr/>
-        <p:nvPr/>
-      </p:nvGrpSpPr>
-      <p:grpSpPr/>
+      <p:grpSpPr>
+        <a:xfrm>
+          <a:off x="0" y="0"/>
+          <a:ext cx="0" cy="0"/>
+          <a:chOff x="0" y="0"/>
+          <a:chExt cx="0" cy="0"/>
+        </a:xfrm>
+      </p:grpSpPr>
       <p:pic>
         <p:nvPicPr>
           <p:cNvPr id="2" name="Picture 1" descr="slide_14.png"/>
@@ -3344,7 +3181,7 @@
 </file>
 
 <file path=ppt/slides/slide2.xml><?xml version="1.0" encoding="utf-8"?>
-<p:sld xmlns:a="http://schemas.openxmlformats.org/drawingml/2006/main" xmlns:p="http://schemas.openxmlformats.org/presentationml/2006/main" xmlns:r="http://schemas.openxmlformats.org/officeDocument/2006/relationships">
+<p:sld xmlns:a="http://schemas.openxmlformats.org/drawingml/2006/main" xmlns:r="http://schemas.openxmlformats.org/officeDocument/2006/relationships" xmlns:p="http://schemas.openxmlformats.org/presentationml/2006/main">
   <p:cSld>
     <p:spTree>
       <p:nvGrpSpPr>
@@ -3352,7 +3189,14 @@
         <p:cNvGrpSpPr/>
         <p:nvPr/>
       </p:nvGrpSpPr>
-      <p:grpSpPr/>
+      <p:grpSpPr>
+        <a:xfrm>
+          <a:off x="0" y="0"/>
+          <a:ext cx="0" cy="0"/>
+          <a:chOff x="0" y="0"/>
+          <a:chExt cx="0" cy="0"/>
+        </a:xfrm>
+      </p:grpSpPr>
       <p:pic>
         <p:nvPicPr>
           <p:cNvPr id="2" name="Picture 1" descr="slide_02.png"/>
@@ -3386,7 +3230,7 @@
 </file>
 
 <file path=ppt/slides/slide3.xml><?xml version="1.0" encoding="utf-8"?>
-<p:sld xmlns:a="http://schemas.openxmlformats.org/drawingml/2006/main" xmlns:p="http://schemas.openxmlformats.org/presentationml/2006/main" xmlns:r="http://schemas.openxmlformats.org/officeDocument/2006/relationships">
+<p:sld xmlns:a="http://schemas.openxmlformats.org/drawingml/2006/main" xmlns:r="http://schemas.openxmlformats.org/officeDocument/2006/relationships" xmlns:p="http://schemas.openxmlformats.org/presentationml/2006/main">
   <p:cSld>
     <p:spTree>
       <p:nvGrpSpPr>
@@ -3394,7 +3238,14 @@
         <p:cNvGrpSpPr/>
         <p:nvPr/>
       </p:nvGrpSpPr>
-      <p:grpSpPr/>
+      <p:grpSpPr>
+        <a:xfrm>
+          <a:off x="0" y="0"/>
+          <a:ext cx="0" cy="0"/>
+          <a:chOff x="0" y="0"/>
+          <a:chExt cx="0" cy="0"/>
+        </a:xfrm>
+      </p:grpSpPr>
       <p:pic>
         <p:nvPicPr>
           <p:cNvPr id="2" name="Picture 1" descr="slide_03.png"/>
@@ -3428,7 +3279,7 @@
 </file>
 
 <file path=ppt/slides/slide4.xml><?xml version="1.0" encoding="utf-8"?>
-<p:sld xmlns:a="http://schemas.openxmlformats.org/drawingml/2006/main" xmlns:p="http://schemas.openxmlformats.org/presentationml/2006/main" xmlns:r="http://schemas.openxmlformats.org/officeDocument/2006/relationships">
+<p:sld xmlns:a="http://schemas.openxmlformats.org/drawingml/2006/main" xmlns:r="http://schemas.openxmlformats.org/officeDocument/2006/relationships" xmlns:p="http://schemas.openxmlformats.org/presentationml/2006/main">
   <p:cSld>
     <p:spTree>
       <p:nvGrpSpPr>
@@ -3436,7 +3287,14 @@
         <p:cNvGrpSpPr/>
         <p:nvPr/>
       </p:nvGrpSpPr>
-      <p:grpSpPr/>
+      <p:grpSpPr>
+        <a:xfrm>
+          <a:off x="0" y="0"/>
+          <a:ext cx="0" cy="0"/>
+          <a:chOff x="0" y="0"/>
+          <a:chExt cx="0" cy="0"/>
+        </a:xfrm>
+      </p:grpSpPr>
       <p:pic>
         <p:nvPicPr>
           <p:cNvPr id="2" name="Picture 1" descr="slide_04.png"/>
@@ -3470,7 +3328,7 @@
 </file>
 
 <file path=ppt/slides/slide5.xml><?xml version="1.0" encoding="utf-8"?>
-<p:sld xmlns:a="http://schemas.openxmlformats.org/drawingml/2006/main" xmlns:p="http://schemas.openxmlformats.org/presentationml/2006/main" xmlns:r="http://schemas.openxmlformats.org/officeDocument/2006/relationships">
+<p:sld xmlns:a="http://schemas.openxmlformats.org/drawingml/2006/main" xmlns:r="http://schemas.openxmlformats.org/officeDocument/2006/relationships" xmlns:p="http://schemas.openxmlformats.org/presentationml/2006/main">
   <p:cSld>
     <p:spTree>
       <p:nvGrpSpPr>
@@ -3478,7 +3336,14 @@
         <p:cNvGrpSpPr/>
         <p:nvPr/>
       </p:nvGrpSpPr>
-      <p:grpSpPr/>
+      <p:grpSpPr>
+        <a:xfrm>
+          <a:off x="0" y="0"/>
+          <a:ext cx="0" cy="0"/>
+          <a:chOff x="0" y="0"/>
+          <a:chExt cx="0" cy="0"/>
+        </a:xfrm>
+      </p:grpSpPr>
       <p:pic>
         <p:nvPicPr>
           <p:cNvPr id="2" name="Picture 1" descr="slide_05.png"/>
@@ -3512,7 +3377,7 @@
 </file>
 
 <file path=ppt/slides/slide6.xml><?xml version="1.0" encoding="utf-8"?>
-<p:sld xmlns:a="http://schemas.openxmlformats.org/drawingml/2006/main" xmlns:p="http://schemas.openxmlformats.org/presentationml/2006/main" xmlns:r="http://schemas.openxmlformats.org/officeDocument/2006/relationships">
+<p:sld xmlns:a="http://schemas.openxmlformats.org/drawingml/2006/main" xmlns:r="http://schemas.openxmlformats.org/officeDocument/2006/relationships" xmlns:p="http://schemas.openxmlformats.org/presentationml/2006/main">
   <p:cSld>
     <p:spTree>
       <p:nvGrpSpPr>
@@ -3520,7 +3385,14 @@
         <p:cNvGrpSpPr/>
         <p:nvPr/>
       </p:nvGrpSpPr>
-      <p:grpSpPr/>
+      <p:grpSpPr>
+        <a:xfrm>
+          <a:off x="0" y="0"/>
+          <a:ext cx="0" cy="0"/>
+          <a:chOff x="0" y="0"/>
+          <a:chExt cx="0" cy="0"/>
+        </a:xfrm>
+      </p:grpSpPr>
       <p:pic>
         <p:nvPicPr>
           <p:cNvPr id="2" name="Picture 1" descr="slide_06.png"/>
@@ -3554,7 +3426,7 @@
 </file>
 
 <file path=ppt/slides/slide7.xml><?xml version="1.0" encoding="utf-8"?>
-<p:sld xmlns:a="http://schemas.openxmlformats.org/drawingml/2006/main" xmlns:p="http://schemas.openxmlformats.org/presentationml/2006/main" xmlns:r="http://schemas.openxmlformats.org/officeDocument/2006/relationships">
+<p:sld xmlns:a="http://schemas.openxmlformats.org/drawingml/2006/main" xmlns:r="http://schemas.openxmlformats.org/officeDocument/2006/relationships" xmlns:p="http://schemas.openxmlformats.org/presentationml/2006/main">
   <p:cSld>
     <p:spTree>
       <p:nvGrpSpPr>
@@ -3562,7 +3434,14 @@
         <p:cNvGrpSpPr/>
         <p:nvPr/>
       </p:nvGrpSpPr>
-      <p:grpSpPr/>
+      <p:grpSpPr>
+        <a:xfrm>
+          <a:off x="0" y="0"/>
+          <a:ext cx="0" cy="0"/>
+          <a:chOff x="0" y="0"/>
+          <a:chExt cx="0" cy="0"/>
+        </a:xfrm>
+      </p:grpSpPr>
       <p:pic>
         <p:nvPicPr>
           <p:cNvPr id="2" name="Picture 1" descr="slide_07.png"/>
@@ -3596,7 +3475,7 @@
 </file>
 
 <file path=ppt/slides/slide8.xml><?xml version="1.0" encoding="utf-8"?>
-<p:sld xmlns:a="http://schemas.openxmlformats.org/drawingml/2006/main" xmlns:p="http://schemas.openxmlformats.org/presentationml/2006/main" xmlns:r="http://schemas.openxmlformats.org/officeDocument/2006/relationships">
+<p:sld xmlns:a="http://schemas.openxmlformats.org/drawingml/2006/main" xmlns:r="http://schemas.openxmlformats.org/officeDocument/2006/relationships" xmlns:p="http://schemas.openxmlformats.org/presentationml/2006/main">
   <p:cSld>
     <p:spTree>
       <p:nvGrpSpPr>
@@ -3604,7 +3483,14 @@
         <p:cNvGrpSpPr/>
         <p:nvPr/>
       </p:nvGrpSpPr>
-      <p:grpSpPr/>
+      <p:grpSpPr>
+        <a:xfrm>
+          <a:off x="0" y="0"/>
+          <a:ext cx="0" cy="0"/>
+          <a:chOff x="0" y="0"/>
+          <a:chExt cx="0" cy="0"/>
+        </a:xfrm>
+      </p:grpSpPr>
       <p:pic>
         <p:nvPicPr>
           <p:cNvPr id="2" name="Picture 1" descr="slide_08.png"/>
@@ -3638,7 +3524,7 @@
 </file>
 
 <file path=ppt/slides/slide9.xml><?xml version="1.0" encoding="utf-8"?>
-<p:sld xmlns:a="http://schemas.openxmlformats.org/drawingml/2006/main" xmlns:p="http://schemas.openxmlformats.org/presentationml/2006/main" xmlns:r="http://schemas.openxmlformats.org/officeDocument/2006/relationships">
+<p:sld xmlns:a="http://schemas.openxmlformats.org/drawingml/2006/main" xmlns:r="http://schemas.openxmlformats.org/officeDocument/2006/relationships" xmlns:p="http://schemas.openxmlformats.org/presentationml/2006/main">
   <p:cSld>
     <p:spTree>
       <p:nvGrpSpPr>
@@ -3646,10 +3532,17 @@
         <p:cNvGrpSpPr/>
         <p:nvPr/>
       </p:nvGrpSpPr>
-      <p:grpSpPr/>
+      <p:grpSpPr>
+        <a:xfrm>
+          <a:off x="0" y="0"/>
+          <a:ext cx="0" cy="0"/>
+          <a:chOff x="0" y="0"/>
+          <a:chExt cx="0" cy="0"/>
+        </a:xfrm>
+      </p:grpSpPr>
       <p:pic>
         <p:nvPicPr>
-          <p:cNvPr id="2" name="Picture 1" descr="slide_09.png"/>
+          <p:cNvPr id="2" name="Picture 1" descr="slide_13.png"/>
           <p:cNvPicPr>
             <a:picLocks noChangeAspect="1"/>
           </p:cNvPicPr>

</xml_diff>